<commit_message>
Module 8 reading live
</commit_message>
<xml_diff>
--- a/neural_circuits_affect_and_valence/neural_circuits_affect_and_valence_lecture_3.pptx
+++ b/neural_circuits_affect_and_valence/neural_circuits_affect_and_valence_lecture_3.pptx
@@ -5626,7 +5626,7 @@
                 </a:solidFill>
                 <a:latin typeface="Calibri"/>
               </a:rPr>
-              <a:t>Neural Circuits, Affect, and Valence</a:t>
+              <a:t>Neural Circuits, Valence, and Affect</a:t>
             </a:r>
           </a:p>
           <a:p>
@@ -5638,7 +5638,7 @@
                 </a:solidFill>
                 <a:latin typeface="Calibri"/>
               </a:rPr>
-              <a:t>Lecture 4.3 — The Biology That Runs It</a:t>
+              <a:t>Lecture 4.3 — The Biology of Neural Circuits</a:t>
             </a:r>
           </a:p>
         </p:txBody>

</xml_diff>